<commit_message>
Deck: use the sentry component names from #30 (Countersign, Warden, ...)
Co-Authored-By: Claude Opus 5.5 (1M context) <noreply@anthropic.com>
Claude-Session: https://claude.ai/code/session_01EM8QB3cfhvDaZMFa4vyFS1
</commit_message>
<xml_diff>
--- a/mvp/deck/SentrAI.pptx
+++ b/mvp/deck/SentrAI.pptx
@@ -9787,7 +9787,7 @@
                 </a:solidFill>
                 <a:latin typeface="Segoe UI"/>
               </a:rPr>
-              <a:t>SQL injection lands on a neglected system: crosses 80, Needle approves a 2h block</a:t>
+              <a:t>SQL injection lands on a neglected system: crosses 80, Countersign approves a 2h block</a:t>
             </a:r>
           </a:p>
         </p:txBody>
@@ -10065,7 +10065,7 @@
                 </a:solidFill>
                 <a:latin typeface="Segoe UI"/>
               </a:rPr>
-              <a:t>Needle approves → IP blocked for 2h → evidence report → a human decides</a:t>
+              <a:t>Countersign approves → IP blocked for 2h → evidence report → a human decides</a:t>
             </a:r>
           </a:p>
         </p:txBody>
@@ -10670,7 +10670,7 @@
                 </a:solidFill>
                 <a:latin typeface="Segoe UI"/>
               </a:rPr>
-              <a:t>IP blocked, 2h expiry, approved by Needle</a:t>
+              <a:t>IP blocked, 2h expiry, approved by Countersign</a:t>
             </a:r>
           </a:p>
         </p:txBody>
@@ -10879,7 +10879,7 @@
                 </a:solidFill>
                 <a:latin typeface="Segoe UI"/>
               </a:rPr>
-              <a:t>#42 Needle approved</a:t>
+              <a:t>#42 Countersign approved</a:t>
             </a:r>
           </a:p>
         </p:txBody>

</xml_diff>